<commit_message>
docs: cập nhật slide bảo vệ bản cuối
</commit_message>
<xml_diff>
--- a/presentation/phan-loai-van-ban-naive-bayes-v2.pptx
+++ b/presentation/phan-loai-van-ban-naive-bayes-v2.pptx
@@ -521,7 +521,7 @@
           <a:lstStyle xmlns:a="http://schemas.openxmlformats.org/drawingml/2006/main"/>
           <a:p xmlns:a="http://schemas.openxmlformats.org/drawingml/2006/main">
             <a:r>
-              <a:t>Tóm tắt: MNB phân loại được bốn chủ đề với macro F1 0.8687 khi dùng TF-IDF. Giới hạn: dữ liệu tiếng Anh, bốn lớp, một tập test, 42 văn bản test rỗng sau lọc. Hướng mở rộng: dữ liệu tiếng Việt có nhãn, validation riêng, thử n-gram. Nguồn đầy đủ trong docs/bao-cao.md. Thành viên 3 kết thúc và mời câu hỏi.</a:t>
+              <a:t>Tóm tắt: MNB phân loại được bốn chủ đề với Test Accuracy 88,52% và Macro F1 88,33% với α=0.1. Hệ thống đạt 16/16 test cases pytest, tích hợp GitHub Actions CI, cảnh báo UX, giải thích đặc trưng TF-IDF và triển khai Streamlit. Giới hạn: dữ liệu tiếng Anh, bốn lớp, một tập test, 42 văn bản test rỗng sau lọc. Hướng mở rộng: dữ liệu tiếng Việt có nhãn, validation riêng, thử n-gram. Nguồn đầy đủ trong docs/bao-cao.md. Thành viên 3 kết thúc và mời câu hỏi.</a:t>
             </a:r>
           </a:p>
         </p:txBody>
@@ -1011,7 +1011,7 @@
           <a:lstStyle xmlns:a="http://schemas.openxmlformats.org/drawingml/2006/main"/>
           <a:p xmlns:a="http://schemas.openxmlformats.org/drawingml/2006/main">
             <a:r>
-              <a:t>Nguồn: results/metrics.json, tạo bởi src/run_experiment.py với scikit-learn 1.7.2. Accuracy Count 0.8544, TF-IDF 0.8718; macro F1 Count 0.8520, TF-IDF 0.8687. Chênh lệch chỉ áp dụng cho cấu hình này. Thành viên 3 trình bày.</a:t>
+              <a:t>Nguồn: results/metrics.json, tạo bởi src/run_experiment.py với scikit-learn 1.7.2. Cơ sở (α=1.0): Accuracy 87,18%, Macro F1 86,87% -&gt; Tối ưu (α=0.1): Accuracy 88,52%, Macro F1 88,33%. Chênh lệch chỉ áp dụng cho cấu hình này. Thành viên 3 trình bày.</a:t>
             </a:r>
           </a:p>
         </p:txBody>
@@ -1689,7 +1689,7 @@
           <c:idx val="0"/>
           <c:order val="0"/>
           <c:tx>
-            <c:v>Bag of Words</c:v>
+            <c:v>Cơ sở (α=1.0)</c:v>
           </c:tx>
           <c:spPr>
             <a:solidFill xmlns:a="http://schemas.openxmlformats.org/drawingml/2006/main">
@@ -1717,10 +1717,10 @@
                 <c:formatCode>General</c:formatCode>
                 <c:ptCount val="2"/>
                 <c:pt idx="0">
-                  <c:v>85.44</c:v>
+                  <c:v>88.52</c:v>
                 </c:pt>
                 <c:pt idx="1">
-                  <c:v>85.2</c:v>
+                  <c:v>88.33</c:v>
                 </c:pt>
               </c:numCache>
             </c:numRef>
@@ -1730,7 +1730,7 @@
           <c:idx val="1"/>
           <c:order val="1"/>
           <c:tx>
-            <c:v>TF-IDF</c:v>
+            <c:v>Tối ưu (α=0.1)</c:v>
           </c:tx>
           <c:spPr>
             <a:solidFill xmlns:a="http://schemas.openxmlformats.org/drawingml/2006/main">
@@ -1758,10 +1758,10 @@
                 <c:formatCode>General</c:formatCode>
                 <c:ptCount val="2"/>
                 <c:pt idx="0">
-                  <c:v>87.18</c:v>
+                  <c:v>88.52</c:v>
                 </c:pt>
                 <c:pt idx="1">
-                  <c:v>86.87</c:v>
+                  <c:v>88.33</c:v>
                 </c:pt>
               </c:numCache>
             </c:numRef>
@@ -2340,7 +2340,7 @@
                 <a:ea typeface="Arial"/>
                 <a:cs typeface="Arial"/>
               </a:rPr>
-              <a:t>Macro F1 tốt nhất trong thử nghiệm: 0,8687 với TF-IDF</a:t>
+              <a:t>Mô hình tối ưu α=0.1: Test Accuracy 88,52%, Macro F1 88,33%</a:t>
             </a:r>
           </a:p>
         </p:txBody>
@@ -2454,7 +2454,7 @@
                 <a:ea typeface="Arial"/>
                 <a:cs typeface="Arial"/>
               </a:rPr>
-              <a:t>Bước tiếp: dữ liệu tiếng Việt và tập validation riêng</a:t>
+              <a:t>16 kiểm thử pytest đạt 100%, CI Pipeline xanh, web Streamlit Cloud &amp; Offline</a:t>
             </a:r>
           </a:p>
         </p:txBody>
@@ -5923,7 +5923,7 @@
                 <a:ea typeface="Arial"/>
                 <a:cs typeface="Arial"/>
               </a:rPr>
-              <a:t>Cùng MultinomialNB, α = 1</a:t>
+              <a:t>MultinomialNB: Tối ưu α = 0.1 qua 5-Fold CV</a:t>
             </a:r>
           </a:p>
         </p:txBody>
@@ -5980,7 +5980,7 @@
                 <a:ea typeface="Arial"/>
                 <a:cs typeface="Arial"/>
               </a:rPr>
-              <a:t>So sánh CountVectorizer và TfidfVectorizer</a:t>
+              <a:t>TfidfVectorizer 13.068 đặc trưng, chống Data Leakage</a:t>
             </a:r>
           </a:p>
         </p:txBody>
@@ -6253,7 +6253,7 @@
                 <a:ea typeface="Arial"/>
                 <a:cs typeface="Arial"/>
               </a:rPr>
-              <a:t>Đơn vị: %  ·  TF-IDF cao hơn khoảng 1,7 điểm phần trăm</a:t>
+              <a:t>Đơn vị: %  ·  Accuracy: 88,52% (+1,34%) · Macro F1: 88,33% (+1,46%) với α=0.1</a:t>
             </a:r>
           </a:p>
         </p:txBody>

</xml_diff>